<commit_message>
Sjöskolan v40: implement the audit's content suggestions
- Worked examples no longer reveal exercise answers: new numbers on
  v40_02 slides 8 and 21 and v40_03 slides 6, 7 and 23 (figures updated to
  the new proportions).
- Ship context: 440/690 V peak values, energy from shore connection,
  capacitor banks rarely used aboard and stored charge, VFD harmonics.
- Safety line on v40_01 slide 19: no earthed scope probe on the mains,
  IT networks aboard.
- Subscript indices (X_L, X_C, U_R, Q_C) in decks, figures and lab.
- Remove the reference to speaker notes that the student decks lack
  (weeks 39 and 40).

Co-Authored-By: Claude Opus 5.5 <noreply@anthropic.com>
Claude-Session: https://claude.ai/code/session_011V9KjBb53XrDm23Dw58SH3
</commit_message>
<xml_diff>
--- a/sjoskolan/vecka-39/aktuell/v39_01_Effekt_och_energi_elev.pptx
+++ b/sjoskolan/vecka-39/aktuell/v39_01_Effekt_och_energi_elev.pptx
@@ -14342,64 +14342,6 @@
       </p:sp>
       <p:sp>
         <p:nvSpPr>
-          <p:cNvPr id="5" name="Källor och lärarstöd finns även i bildanteckningarna.">
-            <a:extLst xmlns:a="http://schemas.openxmlformats.org/drawingml/2006/main">
-              <a:ext uri="{FF2B5EF4-FFF2-40B4-BE49-F238E27FC236}">
-                <a16:creationId xmlns:a16="http://schemas.microsoft.com/office/drawing/2014/main" id="{20D59374-055D-408B-A093-6D3A29FB9B4C}"/>
-              </a:ext>
-            </a:extLst>
-          </p:cNvPr>
-          <p:cNvSpPr>
-            <a:spLocks xmlns:a="http://schemas.openxmlformats.org/drawingml/2006/main" noGrp="1"/>
-          </p:cNvSpPr>
-          <p:nvPr/>
-        </p:nvSpPr>
-        <p:spPr>
-          <a:xfrm xmlns:a="http://schemas.openxmlformats.org/drawingml/2006/main">
-            <a:off x="762000" y="5676900"/>
-            <a:ext cx="7620000" cy="352425"/>
-          </a:xfrm>
-          <a:prstGeom xmlns:a="http://schemas.openxmlformats.org/drawingml/2006/main" prst="rect">
-            <a:avLst/>
-          </a:prstGeom>
-          <a:noFill xmlns:a="http://schemas.openxmlformats.org/drawingml/2006/main"/>
-          <a:ln xmlns:a="http://schemas.openxmlformats.org/drawingml/2006/main" w="0">
-            <a:noFill/>
-          </a:ln>
-        </p:spPr>
-        <p:txBody>
-          <a:bodyPr xmlns:a="http://schemas.openxmlformats.org/drawingml/2006/main" wrap="square" lIns="0" tIns="0" rIns="0" bIns="0" anchor="t">
-            <a:noAutofit/>
-          </a:bodyPr>
-          <a:lstStyle xmlns:a="http://schemas.openxmlformats.org/drawingml/2006/main"/>
-          <a:p xmlns:a="http://schemas.openxmlformats.org/drawingml/2006/main">
-            <a:pPr algn="l">
-              <a:buNone/>
-              <a:defRPr sz="1800" b="0">
-                <a:solidFill>
-                  <a:srgbClr val="111111"/>
-                </a:solidFill>
-                <a:latin typeface="Calibri"/>
-                <a:ea typeface="Calibri"/>
-                <a:cs typeface="Calibri"/>
-              </a:defRPr>
-            </a:pPr>
-            <a:r>
-              <a:rPr sz="1800" b="0">
-                <a:solidFill>
-                  <a:srgbClr val="111111"/>
-                </a:solidFill>
-                <a:latin typeface="Calibri"/>
-                <a:ea typeface="Calibri"/>
-                <a:cs typeface="Calibri"/>
-              </a:rPr>
-              <a:t>Källor och lärarstöd finns även i bildanteckningarna.</a:t>
-            </a:r>
-          </a:p>
-        </p:txBody>
-      </p:sp>
-      <p:sp>
-        <p:nvSpPr>
           <p:cNvPr id="6" name="22">
             <a:extLst xmlns:a="http://schemas.openxmlformats.org/drawingml/2006/main">
               <a:ext uri="{FF2B5EF4-FFF2-40B4-BE49-F238E27FC236}">

</xml_diff>

<commit_message>
Sjöskolan: samma notation i hela kursen, index i multimetersimulatorn
Co-Authored-By: Claude Opus 5.5 <noreply@anthropic.com>
Claude-Session: https://claude.ai/code/session_011V9KjBb53XrDm23Dw58SH3
</commit_message>
<xml_diff>
--- a/sjoskolan/vecka-39/aktuell/v39_01_Effekt_och_energi_elev.pptx
+++ b/sjoskolan/vecka-39/aktuell/v39_01_Effekt_och_energi_elev.pptx
@@ -3512,6 +3512,10 @@
             <a:noFill/>
           </a:ln>
         </p:spPr>
+        <p:txBody xmlns:a="http://schemas.openxmlformats.org/drawingml/2006/main">
+          <a:bodyPr/>
+          <a:p/>
+        </p:txBody>
       </p:sp>
       <p:sp>
         <p:nvSpPr>
@@ -6102,7 +6106,29 @@
                 <a:ea typeface="Calibri"/>
                 <a:cs typeface="Calibri"/>
               </a:rPr>
-              <a:t>/η; Pförlust = P</a:t>
+              <a:t>/η; P</a:t>
+            </a:r>
+            <a:r>
+              <a:rPr sz="2400" b="1" baseline="-25000">
+                <a:solidFill>
+                  <a:srgbClr val="064F91"/>
+                </a:solidFill>
+                <a:latin typeface="Calibri"/>
+                <a:ea typeface="Calibri"/>
+                <a:cs typeface="Calibri"/>
+              </a:rPr>
+              <a:t>förlust</a:t>
+            </a:r>
+            <a:r>
+              <a:rPr sz="2400" b="1">
+                <a:solidFill>
+                  <a:srgbClr val="064F91"/>
+                </a:solidFill>
+                <a:latin typeface="Calibri"/>
+                <a:ea typeface="Calibri"/>
+                <a:cs typeface="Calibri"/>
+              </a:rPr>
+              <a:t> = P</a:t>
             </a:r>
             <a:r>
               <a:rPr sz="2400" b="1" baseline="-25000">
@@ -8839,7 +8865,29 @@
                 <a:ea typeface="Calibri"/>
                 <a:cs typeface="Calibri"/>
               </a:rPr>
-              <a:t>ΔU = I · R     Pförlust = I² · R</a:t>
+              <a:t>ΔU = I · R     P</a:t>
+            </a:r>
+            <a:r>
+              <a:rPr sz="2925" b="1" baseline="-25000">
+                <a:solidFill>
+                  <a:srgbClr val="064F91"/>
+                </a:solidFill>
+                <a:latin typeface="Calibri"/>
+                <a:ea typeface="Calibri"/>
+                <a:cs typeface="Calibri"/>
+              </a:rPr>
+              <a:t>förlust</a:t>
+            </a:r>
+            <a:r>
+              <a:rPr sz="2925" b="1">
+                <a:solidFill>
+                  <a:srgbClr val="064F91"/>
+                </a:solidFill>
+                <a:latin typeface="Calibri"/>
+                <a:ea typeface="Calibri"/>
+                <a:cs typeface="Calibri"/>
+              </a:rPr>
+              <a:t> = I² · R</a:t>
             </a:r>
           </a:p>
         </p:txBody>
@@ -9660,7 +9708,29 @@
                 <a:ea typeface="Calibri"/>
                 <a:cs typeface="Calibri"/>
               </a:rPr>
-              <a:t>2. ΔU = 4 · 0,070 = 0,28 V. Ulast = 24 − 0,28 = 23,72 V.</a:t>
+              <a:t>2. ΔU = 4 · 0,070 = 0,28 V. U</a:t>
+            </a:r>
+            <a:r>
+              <a:rPr sz="2063" b="0" baseline="-25000">
+                <a:solidFill>
+                  <a:srgbClr val="111111"/>
+                </a:solidFill>
+                <a:latin typeface="Calibri"/>
+                <a:ea typeface="Calibri"/>
+                <a:cs typeface="Calibri"/>
+              </a:rPr>
+              <a:t>last</a:t>
+            </a:r>
+            <a:r>
+              <a:rPr sz="2063" b="0">
+                <a:solidFill>
+                  <a:srgbClr val="111111"/>
+                </a:solidFill>
+                <a:latin typeface="Calibri"/>
+                <a:ea typeface="Calibri"/>
+                <a:cs typeface="Calibri"/>
+              </a:rPr>
+              <a:t> = 24 − 0,28 = 23,72 V.</a:t>
             </a:r>
           </a:p>
           <a:p xmlns:a="http://schemas.openxmlformats.org/drawingml/2006/main">
@@ -11483,7 +11553,29 @@
                 <a:ea typeface="Calibri"/>
                 <a:cs typeface="Calibri"/>
               </a:rPr>
-              <a:t>Pförlust = I² · R; P</a:t>
+              <a:t>P</a:t>
+            </a:r>
+            <a:r>
+              <a:rPr sz="2400" b="1" baseline="-25000">
+                <a:solidFill>
+                  <a:srgbClr val="064F91"/>
+                </a:solidFill>
+                <a:latin typeface="Calibri"/>
+                <a:ea typeface="Calibri"/>
+                <a:cs typeface="Calibri"/>
+              </a:rPr>
+              <a:t>förlust</a:t>
+            </a:r>
+            <a:r>
+              <a:rPr sz="2400" b="1">
+                <a:solidFill>
+                  <a:srgbClr val="064F91"/>
+                </a:solidFill>
+                <a:latin typeface="Calibri"/>
+                <a:ea typeface="Calibri"/>
+                <a:cs typeface="Calibri"/>
+              </a:rPr>
+              <a:t> = I² · R; P</a:t>
             </a:r>
             <a:r>
               <a:rPr sz="2400" b="1" baseline="-25000">
@@ -16769,7 +16861,18 @@
                 <a:ea typeface="Calibri"/>
                 <a:cs typeface="Calibri"/>
               </a:rPr>
-              <a:t>η = Pᵤₜ / Pᵢₙ</a:t>
+              <a:t>η = Pᵤₜ / P</a:t>
+            </a:r>
+            <a:r>
+              <a:rPr sz="2925" b="1" baseline="-25000">
+                <a:solidFill>
+                  <a:srgbClr val="064F91"/>
+                </a:solidFill>
+                <a:latin typeface="Calibri"/>
+                <a:ea typeface="Calibri"/>
+                <a:cs typeface="Calibri"/>
+              </a:rPr>
+              <a:t>in</a:t>
             </a:r>
           </a:p>
         </p:txBody>
@@ -17126,7 +17229,29 @@
                 <a:ea typeface="Calibri"/>
                 <a:cs typeface="Calibri"/>
               </a:rPr>
-              <a:t>Pᵢₙ = Pᵤₜ/η     E = Pᵢₙt</a:t>
+              <a:t>P</a:t>
+            </a:r>
+            <a:r>
+              <a:rPr sz="2325" b="1" baseline="-25000">
+                <a:solidFill>
+                  <a:srgbClr val="064F91"/>
+                </a:solidFill>
+                <a:latin typeface="Calibri"/>
+                <a:ea typeface="Calibri"/>
+                <a:cs typeface="Calibri"/>
+              </a:rPr>
+              <a:t>in</a:t>
+            </a:r>
+            <a:r>
+              <a:rPr sz="2325" b="1">
+                <a:solidFill>
+                  <a:srgbClr val="064F91"/>
+                </a:solidFill>
+                <a:latin typeface="Calibri"/>
+                <a:ea typeface="Calibri"/>
+                <a:cs typeface="Calibri"/>
+              </a:rPr>
+              <a:t> = Pᵤₜ/η     E = Pᵢₙt</a:t>
             </a:r>
           </a:p>
         </p:txBody>
@@ -17206,7 +17331,29 @@
                 <a:ea typeface="Calibri"/>
                 <a:cs typeface="Calibri"/>
               </a:rPr>
-              <a:t>2. Pᵢₙ = 240/0,60 = 400 W = 0,400 kW.</a:t>
+              <a:t>2. P</a:t>
+            </a:r>
+            <a:r>
+              <a:rPr sz="2063" b="0" baseline="-25000">
+                <a:solidFill>
+                  <a:srgbClr val="111111"/>
+                </a:solidFill>
+                <a:latin typeface="Calibri"/>
+                <a:ea typeface="Calibri"/>
+                <a:cs typeface="Calibri"/>
+              </a:rPr>
+              <a:t>in</a:t>
+            </a:r>
+            <a:r>
+              <a:rPr sz="2063" b="0">
+                <a:solidFill>
+                  <a:srgbClr val="111111"/>
+                </a:solidFill>
+                <a:latin typeface="Calibri"/>
+                <a:ea typeface="Calibri"/>
+                <a:cs typeface="Calibri"/>
+              </a:rPr>
+              <a:t> = 240/0,60 = 400 W = 0,400 kW.</a:t>
             </a:r>
           </a:p>
           <a:p xmlns:a="http://schemas.openxmlformats.org/drawingml/2006/main">

</xml_diff>